<commit_message>
Procesos Básicos III: presentación de De Neys con 2 minutos por expositor
Reparte el guion en cinco partes iguales de 2 minutos (unas 250 palabras
cada una). La diapositiva del modelo pasa del expositor 1 al 2, para que
el primero cuente solo el experimento; las partes 2 y 3 suman un ejemplo
cada una. Las notas del orador y los tiempos se actualizan.

Co-Authored-By: Claude Opus 5.5 <noreply@anthropic.com>
Claude-Session: https://claude.ai/code/session_014TgNuKp3tg1RihixbZ4R3r
</commit_message>
<xml_diff>
--- a/2do Año/Procesos Básicos III/6_Entregables/U03_PresentacionArticulo_FastAndSlowThinking_Diapositivas.pptx
+++ b/2do Año/Procesos Básicos III/6_Entregables/U03_PresentacionArticulo_FastAndSlowThinking_Diapositivas.pptx
@@ -117,28 +117,28 @@
   <p:extLst>
     <p:ext uri="{521415D9-36F7-43E2-AB2F-B90AF26B5E84}">
       <p14:sectionLst xmlns:p14="http://schemas.microsoft.com/office/powerpoint/2010/main">
-        <p14:section name="El experimento" id="{aa2138cb-e4ee-28ee-3d6c-b858ff4d3ba1}">
+        <p14:section name="El experimento" id="{bb5c2cf5-dc4e-a4ed-5a27-684ffc3da75a}">
           <p14:sldIdLst>
             <p14:sldId id="256"/>
             <p14:sldId id="257"/>
             <p14:sldId id="258"/>
             <p14:sldId id="259"/>
-            <p14:sldId id="260"/>
           </p14:sldIdLst>
         </p14:section>
-        <p14:section name="Aciertos teóricos" id="{4520c874-14e5-b3dd-f84a-450dbf9861f2}">
+        <p14:section name="Propuesta y aciertos" id="{5a0703af-ef70-8753-9b07-9c7d8817794e}">
           <p14:sldIdLst>
+            <p14:sldId id="260"/>
             <p14:sldId id="261"/>
             <p14:sldId id="262"/>
           </p14:sldIdLst>
         </p14:section>
-        <p14:section name="Críticas teóricas" id="{cb6ecbf1-81d5-5eac-ec16-347567af2548}">
+        <p14:section name="Críticas teóricas" id="{b873d0fa-bee3-9d28-cfce-fd2a0e343d9f}">
           <p14:sldIdLst>
             <p14:sldId id="263"/>
             <p14:sldId id="264"/>
           </p14:sldIdLst>
         </p14:section>
-        <p14:section name="Cierre" id="{9dad55e7-8fbd-dcf7-d969-0d8894b511b8}">
+        <p14:section name="Cierre" id="{353b8072-4536-0dd9-3c42-eba93df7c1fc}">
           <p14:sldIdLst>
             <p14:sldId id="265"/>
             <p14:sldId id="266"/>
@@ -822,8 +822,8 @@
           <a:p>
             <a:r>
               <a:rPr lang="en-US" dirty="0"/>
-              <a:t>EXPOSITOR/A 1 · 0:15
-Buenas tardes. Vamos a presentar Advancing theorizing about fast-and-slow thinking, de Wim De Neys, publicado en 2023 en Behavioral and Brain Sciences. Yo les voy a contar qué problema plantea y cómo se investigó; después vienen los aciertos y las críticas.</a:t>
+              <a:t>EXPOSITOR/A 1 · 0:15 (parte 1: 2:00)
+Buenas tardes. Vamos a presentar Advancing theorizing about fast-and-slow thinking, de Wim De Neys, publicado en 2023 en Behavioral and Brain Sciences. Yo les cuento cómo se investigó; después vienen la propuesta, los aciertos y las críticas.</a:t>
             </a:r>
             <a:endParaRPr lang="en-US" dirty="0"/>
           </a:p>
@@ -911,7 +911,7 @@
           <a:p>
             <a:r>
               <a:rPr lang="en-US" dirty="0"/>
-              <a:t>EXPOSITOR/A 5 · 0:50
+              <a:t>EXPOSITOR/A 5 · 0:40
 En síntesis: el artículo muestra que la exclusividad y el mecanismo de cambio son el mismo problema, y propone un modelo que conserva la distinción entre intuición y deliberación. Sus límites: es verbal, la automatización está poco probada y las tareas son artificiales.
 Y les preguntamos: ¿les pasó que algo que al principio tenían que pensar con esfuerzo, después les saliera "solo"? Por ejemplo, en estadística. Esa respuesta automática, ¿es una intuición, como dice De Neys, o sigue siendo pensamiento deliberado, pero más rápido?</a:t>
             </a:r>
@@ -1089,9 +1089,8 @@
           <a:p>
             <a:r>
               <a:rPr lang="en-US" dirty="0"/>
-              <a:t>EXPOSITOR/A 1 · 0:45
-Todos conocemos la idea de los dos sistemas: el sistema 1, intuitivo, rápido y sin esfuerzo, y el sistema 2, deliberado, lento y costoso. Con ella se explican los sesgos de razonamiento, el juicio moral y la cooperación.
-De Neys cuestiona dos supuestos. La exclusividad: que la respuesta correcta está fuera del alcance de la intuición, y que para acertar el sistema 2 tiene que corregir una intuición equivocada. Y el mecanismo de cambio: cómo sabe una persona, sola, cuándo dejar la intuición y ponerse a pensar. Su hipótesis es que, mientras se sostenga la exclusividad, el cambio no se puede explicar.</a:t>
+              <a:t>EXPOSITOR/A 1 · 0:30
+Todos conocemos la idea de los dos sistemas: el sistema 1, intuitivo, rápido y sin esfuerzo, y el sistema 2, deliberado, lento y costoso. De Neys cuestiona dos supuestos. La exclusividad: que la respuesta correcta solo la da el sistema 2, que tiene que corregir una intuición equivocada. Y el mecanismo de cambio: cómo sabe una persona, sola, cuándo dejar la intuición y ponerse a pensar.</a:t>
             </a:r>
             <a:endParaRPr lang="en-US" dirty="0"/>
           </a:p>
@@ -1179,9 +1178,9 @@
           <a:p>
             <a:r>
               <a:rPr lang="en-US" dirty="0"/>
-              <a:t>EXPOSITOR/A 1 · 1:00
-El artículo es una revisión teórica, no un experimento propio, pero toda la revisión se apoya en un tipo de experimento. Tomemos este problema: "Un bate y una pelota cuestan 1,10 dólares. El bate cuesta 1 dólar más que la pelota. ¿Cuánto cuesta la pelota?". La respuesta que salta es 10 centavos; la correcta es 5.
-En el paradigma de dos respuestas, la persona responde dos veces. Primero, con presión de tiempo y haciendo a la vez una tarea de memoria, para que no pueda deliberar. Después, sin límite. En cada respuesta se miden el tiempo y la confianza, y se comparan versiones con conflicto, como esta, y sin conflicto, donde intuición y lógica coinciden. Se usó en razonamiento lógico, juicio moral y conducta prosocial.</a:t>
+              <a:t>EXPOSITOR/A 1 · 0:45
+El artículo es una revisión teórica, pero se apoya en un tipo de experimento. Por ejemplo: "Un bate y una pelota cuestan 1,10 dólares. El bate cuesta 1 dólar más que la pelota. ¿Cuánto cuesta la pelota?". La respuesta que salta es 10 centavos; la correcta es 5.
+En el paradigma de dos respuestas, la persona responde dos veces. Primero, con presión de tiempo y haciendo a la vez una tarea de memoria, para que no pueda deliberar. Después, sin límite. Se miden el tiempo y la confianza, y se comparan problemas con conflicto, como este, y sin conflicto.</a:t>
             </a:r>
             <a:endParaRPr lang="en-US" dirty="0"/>
           </a:p>
@@ -1269,8 +1268,8 @@
           <a:p>
             <a:r>
               <a:rPr lang="en-US" dirty="0"/>
-              <a:t>EXPOSITOR/A 1 · 0:35
-Tres resultados. Uno: impedir la deliberación baja el acierto mucho menos de lo esperado, de un 62 % a un 52 % según un metaanálisis (Lawson et al., 2020, como se citó en De Neys, 2023a). Dos: quienes aciertan al final, en general ya habían acertado en la respuesta intuitiva. Tres: incluso quienes se equivocan tardan más y confían menos cuando hay conflicto; algo detecta el choque, aunque no lo corrijan.</a:t>
+              <a:t>EXPOSITOR/A 1 · 0:30
+Tres resultados. Uno: impedir la deliberación baja el acierto mucho menos de lo esperado, de un 62 % a un 52 % (Lawson et al., 2020, como se citó en De Neys, 2023a). Dos: quienes aciertan al final ya acertaban en la respuesta intuitiva. Tres: incluso quienes se equivocan tardan más y confían menos cuando hay conflicto.</a:t>
             </a:r>
             <a:endParaRPr lang="en-US" dirty="0"/>
           </a:p>
@@ -1358,8 +1357,8 @@
           <a:p>
             <a:r>
               <a:rPr lang="en-US" dirty="0"/>
-              <a:t>EXPOSITOR/A 1 · 0:35
-De ahí sale su modelo. El sistema 1 activa varias intuiciones de distinta fuerza, incluida la lógica. Un monitoreo intuitivo compara esas fuerzas: si son parecidas, la incertidumbre es alta y, pasado un umbral, se activa el sistema 2. La deliberación puede corregir, pero también solo justificar. Y una retroalimentación ajusta las intuiciones y apaga la deliberación cuando baja la incertidumbre. Conclusión: todo modelo dual viable tiene que ser no exclusivo.
+              <a:t>EXPOSITOR/A 2 · 0:35 (parte 2: 2:00)
+A partir de esos resultados, De Neys propone un modelo. El sistema 1 activa varias intuiciones de distinta fuerza, incluida la lógica. Un monitoreo intuitivo compara esas fuerzas: si son parecidas, la incertidumbre es alta y, pasado un umbral, se activa el sistema 2. La deliberación puede corregir, pero también solo justificar. Y una retroalimentación ajusta las intuiciones y apaga la deliberación. Conclusión: todo modelo dual viable tiene que ser no exclusivo.
 [NO LEER] Si preguntan por la fórmula (ejemplo nuestro, no del texto): U = 1 − |I1 − I2|. Si la intuición "10 centavos" tiene fuerza 0,8 y la de "5 centavos" 0,3, U = 1 − 0,5 = 0,5. Si las dos valen 0,6, U = 1 − 0 = 1: máxima incertidumbre, y ahí se activa el sistema 2.
 Si preguntan por qué los modelos anteriores no explican el cambio: si el sistema 2 vigila al 1, ya tendría que estar activo para detectar el conflicto; y un "sistema 3" que los compare lleva a una regresión infinita (De Neys, 2023a, pp. 6-7).</a:t>
             </a:r>
@@ -1450,9 +1449,8 @@
             <a:r>
               <a:rPr lang="en-US" dirty="0"/>
               <a:t>EXPOSITOR/A 2 · 1:25
-El primer acierto es que De Neys hace explícito un supuesto que vimos en la materia: el de la teoría heurístico-analítica de Evans.
-Para Evans, el razonamiento tiene un estadio heurístico, preconsciente y rápido, que selecciona la información relevante, y un estadio analítico, donde se deduce. Los sesgos se atribuyen al primero y la competencia lógica, al segundo (Valiña y Martín, 2014, pp. 19-20, 22). Esa es justamente la exclusividad que critica De Neys, y su crítica muestra lo que a Evans le faltaba: qué hace que intervenga el estadio analítico. Además, que la deliberación muchas veces justifique la intuición en vez de corregirla coincide con Evans: "las personas cometen errores en razonamiento porque piensan selectivamente" (Valiña y Martín, 2014, p. 20).
-Hay un segundo aporte. A Tversky y Kahneman se les criticó que su teoría es más descriptiva que explicativa: describen fenómenos, pero no los procesos que los producen (Pérez Echeverría y Bautista, 2014, p. 18). De Neys hace lo contrario: propone un mecanismo —fuerza de las intuiciones, incertidumbre, umbral y retroalimentación— del que salen preguntas nuevas que se pueden poner a prueba.</a:t>
+El primer acierto es que hace explícito un supuesto que vimos en la materia: el de la teoría heurístico-analítica de Evans. Para Evans hay un estadio heurístico, preconsciente, que selecciona la información relevante, y uno analítico, donde se deduce. Los sesgos se atribuyen al primero y la competencia, al segundo (Valiña y Martín, 2014, pp. 19-20, 22). Esa es justamente la exclusividad, y De Neys muestra lo que a Evans le faltaba: qué hace que intervenga lo analítico. Además, que deliberar a veces solo justifique la intuición coincide con Evans: "las personas cometen errores en razonamiento porque piensan selectivamente" (Valiña y Martín, 2014, p. 20). Por ejemplo, alguien puede deliberar solo para encontrar razones a favor de los 10 centavos.
+Hay un segundo aporte. A Tversky y Kahneman se les criticó que su teoría es más descriptiva que explicativa (Pérez Echeverría y Bautista, 2014, p. 18). De Neys, en cambio, propone un mecanismo —fuerza de las intuiciones, incertidumbre, umbral y retroalimentación— del que salen preguntas que se pueden poner a prueba.</a:t>
             </a:r>
             <a:endParaRPr lang="en-US" dirty="0"/>
           </a:p>
@@ -1540,11 +1538,11 @@
           <a:p>
             <a:r>
               <a:rPr lang="en-US" dirty="0"/>
-              <a:t>EXPOSITOR/A 3 · 1:20
+              <a:t>EXPOSITOR/A 3 · 2:00
 El segundo acierto es la idea más original del modelo: que la respuesta lógica pueda volverse intuitiva con el aprendizaje. Es lo que vimos en razonamiento probabilístico.
-Fischbein distingue intuiciones primarias, que surgen de la experiencia y se parecen a los sesgos de Tversky y Kahneman, de intuiciones secundarias, logradas por instrucción y esfuerzo deliberado. Y Hogarth dice que la intuición se puede educar hasta acercarse a la norma estadística (Pérez Echeverría y Bautista, 2014, pp. 7-8, 18). Los expertos, además, convierten lo deliberado en tácito (p. 20). La "intuición lógica" de De Neys sería una intuición secundaria.
-El otro acierto es metodológico. Pérez Echeverría critica que los heurísticos, que son implícitos, se estudiaran con tareas que piden respuestas declarativas, y pide la convergencia de métodos diversos (Pérez Echeverría y Bautista, 2014, pp. 18-19). De Neys combina tiempos, confianza, respuestas bajo carga y justificaciones. Y sus datos muestran que lo implícito cuesta declararse: las respuestas correctas intuitivas son difíciles de justificar (De Neys, 2023a, p. 12).
-Pero el modelo también tiene puntos débiles.</a:t>
+Fischbein distingue intuiciones primarias, que surgen de la experiencia y se parecen a los sesgos de Tversky y Kahneman, de intuiciones secundarias, que se logran por instrucción y esfuerzo deliberado. Hogarth agrega que la intuición se puede y se debe educar hasta acercarse a la norma estadística (Pérez Echeverría y Bautista, 2014, pp. 7-8, 18). Y los expertos convierten lo deliberado en tácito: automatizan decisiones que antes les costaban (p. 20). Lo que para el novato es un problema, para el experto es un ejercicio (Pérez Echeverría, 2014, p. 16). Pensemos en un estudiante que al principio calcula una probabilidad paso a paso y, con práctica, la estima de un vistazo. La "intuición lógica" de De Neys sería, en estos términos, una intuición secundaria.
+El otro acierto es metodológico. Pérez Echeverría critica que los heurísticos, que son implícitos, se estudiaran con tareas que piden respuestas declarativas, y pide la convergencia de métodos diversos (Pérez Echeverría y Bautista, 2014, pp. 18-19). De Neys combina cuatro: tiempos de respuesta, confianza, respuestas bajo carga y justificaciones. Y sus datos muestran justamente que lo implícito cuesta declararse: las respuestas correctas intuitivas son difíciles de justificar, a diferencia de las deliberadas (De Neys, 2023a, p. 12).
+Pero el modelo también tiene puntos débiles, y de eso van a hablar mis compañeros.</a:t>
             </a:r>
             <a:endParaRPr lang="en-US" dirty="0"/>
           </a:p>
@@ -1632,8 +1630,8 @@
           <a:p>
             <a:r>
               <a:rPr lang="en-US" dirty="0"/>
-              <a:t>EXPOSITOR/A 4 · 1:40
-La primera crítica es cómo separa el modelo la intuición de la deliberación. El propio De Neys reconoce que no existe un umbral que las separe, así que nunca se puede descartar algo de deliberación en la respuesta rápida (De Neys, 2023a, p. 5). Y su argumento depende de que esa respuesta sea pura intuición.
+              <a:t>EXPOSITOR/A 4 · 2:00
+La primera crítica es cómo separa el modelo la intuición de la deliberación. El propio De Neys reconoce que no existe un umbral que las separe, así que nunca se puede descartar algo de deliberación en la respuesta rápida (De Neys, 2023a, p. 5). Pensemos en el bate y la pelota: si alguien responde en dos segundos, ¿cómo sabemos que no pensó un poco? Y todo su argumento depende de que esa primera respuesta sea pura intuición.
 En la materia vimos que la relación entre lo implícito y lo explícito es más un continuo que una dicotomía (Pérez Echeverría y Bautista, 2014, pp. 18-19), y que la diferencia entre lo deliberado y lo tácito es cuestión de grado (p. 19). Si es así, un modelo que enciende o apaga el sistema 2 al cruzar un umbral traza una frontera que la evidencia no permite trazar.
 La segunda crítica: el modelo sigue siendo verbal. No fija valores para la fuerza de las intuiciones ni para el umbral (De Neys, 2023a, pp. 12, 14). Entonces puede explicar cualquier resultado después de que ocurre: si alguien acierta, su intuición lógica era fuerte; si se equivoca, era débil.
 Es la misma crítica que se le hizo a Tversky y Kahneman: no se puede saber a priori qué heurístico va a actuar (Pérez Echeverría y Bautista, 2014, pp. 17-18). De Neys propone un mecanismo, pero todavía no uno que permita predecir.</a:t>
@@ -1724,10 +1722,11 @@
           <a:p>
             <a:r>
               <a:rPr lang="en-US" dirty="0"/>
-              <a:t>EXPOSITOR/A 5 · 1:20
+              <a:t>EXPOSITOR/A 5 · 1:20 (parte 5: 2:00)
 La segunda crítica apunta a las tareas: toda la evidencia viene de problemas de laboratorio, bien definidos y con poco contenido, como el del bate y la pelota.
-En solución de problemas, la investigación hizo el mismo camino: empezó con problemas sin contenido, que daban más control (Postigo Angón, 2014, p. 8), hasta que el enfoque de expertos y novatos mostró que resolver bien depende del conocimiento del dominio (Pérez Echeverría, 2014, p. 13). Y Pérez Echeverría advierte que estas tareas son muy artificiales y que quizás las normas matemáticas no son el mejor modelo (Pérez Echeverría y Bautista, 2014, p. 16). Evans diría que una cosa es la racionalidad de proceso, ajustarse a la norma, y otra la de propósito, alcanzar los propios objetivos (Valiña y Martín, 2014, p. 21). Entonces, ¿qué pasa con el modelo en los problemas mal definidos de la vida cotidiana, donde no hay respuesta correcta contra la cual medir? El autor lo admite como límite (De Neys, 2023b, p. 68).
-Además, que la lógica se automatice tiene poca evidencia directa (De Neys, 2023a, p. 13), y el autor no usa la tradición de Fischbein, que podría darle sustento.</a:t>
+En solución de problemas, la investigación hizo el mismo camino: empezó con problemas sin contenido, que daban más control (Postigo Angón, 2014, p. 8), hasta que el enfoque de expertos y novatos mostró que resolver bien depende del conocimiento del dominio (Pérez Echeverría, 2014, p. 13). Y Pérez Echeverría advierte que estas tareas son muy artificiales y que quizás las normas matemáticas no son el mejor modelo (Pérez Echeverría y Bautista, 2014, p. 16). Entonces, ¿qué pasa con el modelo en los problemas mal definidos de la vida cotidiana, donde no hay respuesta correcta contra la cual medir? El autor lo admite como límite (De Neys, 2023b, p. 68).
+Además, que la lógica se automatice tiene poca evidencia directa (De Neys, 2023a, p. 13), y el autor no usa la tradición de Fischbein, que podría darle sustento.
+[NO LEER] Si preguntan qué sería "acertar" fuera del laboratorio: Evans distingue la racionalidad de proceso, ajustarse a una norma como la lógica, de la racionalidad de propósito, alcanzar los propios objetivos (Valiña y Martín, 2014, p. 21). En la vida cotidiana importa la segunda, y el modelo solo mide la primera.</a:t>
             </a:r>
             <a:endParaRPr lang="en-US" dirty="0"/>
           </a:p>
@@ -2863,7 +2862,7 @@
                   <a:schemeClr val="bg1"/>
                 </a:solidFill>
               </a:rPr>
-              <a:t>Aciertos teóricos</a:t>
+              <a:t>Propuesta y aciertos</a:t>
             </a:r>
             <a:endParaRPr lang="en-US" sz="1500" dirty="0"/>
           </a:p>
@@ -6078,7 +6077,7 @@
         <p:spPr>
           <a:xfrm>
             <a:off x="457200" y="201168"/>
-            <a:ext cx="1865376" cy="274320"/>
+            <a:ext cx="1664208" cy="274320"/>
           </a:xfrm>
           <a:prstGeom prst="roundRect">
             <a:avLst>
@@ -6086,11 +6085,11 @@
             </a:avLst>
           </a:prstGeom>
           <a:solidFill>
-            <a:srgbClr val="E9A23B"/>
+            <a:srgbClr val="2A8C82"/>
           </a:solidFill>
           <a:ln w="12700">
             <a:solidFill>
-              <a:srgbClr val="E9A23B"/>
+              <a:srgbClr val="2A8C82"/>
             </a:solidFill>
             <a:prstDash val="solid"/>
           </a:ln>
@@ -6105,7 +6104,7 @@
         <p:spPr>
           <a:xfrm>
             <a:off x="457200" y="201168"/>
-            <a:ext cx="1865376" cy="274320"/>
+            <a:ext cx="1664208" cy="274320"/>
           </a:xfrm>
           <a:prstGeom prst="rect">
             <a:avLst/>
@@ -6126,7 +6125,7 @@
                   <a:schemeClr val="bg1"/>
                 </a:solidFill>
               </a:rPr>
-              <a:t>EL EXPERIMENTO</a:t>
+              <a:t>LA PROPUESTA</a:t>
             </a:r>
             <a:endParaRPr lang="en-US" sz="1100" dirty="0"/>
           </a:p>
@@ -9598,7 +9597,7 @@
                   <a:schemeClr val="tx1"/>
                 </a:solidFill>
               </a:rPr>
-              <a:t>Resolver depende del conocimiento del dominio (expertos y novatos). Y la racionalidad de propósito no es la de proceso (Evans).</a:t>
+              <a:t>Resolver depende del conocimiento del dominio (expertos y novatos). En la vida cotidiana, ¿contra qué norma se mide el acierto?</a:t>
             </a:r>
             <a:endParaRPr lang="en-US" sz="1300" dirty="0"/>
           </a:p>
@@ -9759,7 +9758,7 @@
                   <a:schemeClr val="tx2"/>
                 </a:solidFill>
               </a:rPr>
-              <a:t>Postigo Angón (2014, p. 8); Pérez Echeverría (2014, p. 13); Pérez Echeverría y Bautista (2014, p. 16); Valiña y Martín (2014, p. 21); De Neys (2023a, p. 13; 2023b, p. 68)</a:t>
+              <a:t>Postigo Angón (2014, p. 8); Pérez Echeverría (2014, p. 13); Pérez Echeverría y Bautista (2014, p. 16); De Neys (2023a, p. 13; 2023b, p. 68)</a:t>
             </a:r>
             <a:endParaRPr lang="en-US" sz="1000" dirty="0"/>
           </a:p>

</xml_diff>

<commit_message>
Procesos Básicos III: una parte por expositor en la presentación de De Neys
Cada expositor presenta solo su parte durante 2 minutos: 1 el
experimento, 2 y 3 los aciertos, 4 y 5 las críticas. El modelo de De
Neys pasa a ser el contenido del acierto 1, y la crítica 2 recupera el
argumento de Evans sobre racionalidad de proceso y de propósito. El cierre
y la pregunta de la diapositiva 10 quedan para el debate de todo el grupo,
después de la exposición, como pide la consigna.

Co-Authored-By: Claude Opus 5.5 <noreply@anthropic.com>
Claude-Session: https://claude.ai/code/session_014TgNuKp3tg1RihixbZ4R3r
</commit_message>
<xml_diff>
--- a/2do Año/Procesos Básicos III/6_Entregables/U03_PresentacionArticulo_FastAndSlowThinking_Diapositivas.pptx
+++ b/2do Año/Procesos Básicos III/6_Entregables/U03_PresentacionArticulo_FastAndSlowThinking_Diapositivas.pptx
@@ -117,7 +117,7 @@
   <p:extLst>
     <p:ext uri="{521415D9-36F7-43E2-AB2F-B90AF26B5E84}">
       <p14:sectionLst xmlns:p14="http://schemas.microsoft.com/office/powerpoint/2010/main">
-        <p14:section name="El experimento" id="{bb5c2cf5-dc4e-a4ed-5a27-684ffc3da75a}">
+        <p14:section name="El experimento" id="{919fd0fa-91f1-db5b-454c-f084a61c7431}">
           <p14:sldIdLst>
             <p14:sldId id="256"/>
             <p14:sldId id="257"/>
@@ -125,20 +125,20 @@
             <p14:sldId id="259"/>
           </p14:sldIdLst>
         </p14:section>
-        <p14:section name="Propuesta y aciertos" id="{5a0703af-ef70-8753-9b07-9c7d8817794e}">
+        <p14:section name="Aciertos teóricos" id="{31c1914f-de84-7a64-eceb-38d33d280e54}">
           <p14:sldIdLst>
             <p14:sldId id="260"/>
             <p14:sldId id="261"/>
             <p14:sldId id="262"/>
           </p14:sldIdLst>
         </p14:section>
-        <p14:section name="Críticas teóricas" id="{b873d0fa-bee3-9d28-cfce-fd2a0e343d9f}">
+        <p14:section name="Críticas teóricas" id="{96d5d999-0805-7ddb-12d1-5547e2b70cd6}">
           <p14:sldIdLst>
             <p14:sldId id="263"/>
             <p14:sldId id="264"/>
           </p14:sldIdLst>
         </p14:section>
-        <p14:section name="Cierre" id="{353b8072-4536-0dd9-3c42-eba93df7c1fc}">
+        <p14:section name="Debate" id="{d6fa75e0-dac9-d87b-4cbc-0ab77c2d594c}">
           <p14:sldIdLst>
             <p14:sldId id="265"/>
             <p14:sldId id="266"/>
@@ -823,7 +823,7 @@
             <a:r>
               <a:rPr lang="en-US" dirty="0"/>
               <a:t>EXPOSITOR/A 1 · 0:15 (parte 1: 2:00)
-Buenas tardes. Vamos a presentar Advancing theorizing about fast-and-slow thinking, de Wim De Neys, publicado en 2023 en Behavioral and Brain Sciences. Yo les cuento cómo se investigó; después vienen la propuesta, los aciertos y las críticas.</a:t>
+Buenas tardes. Vamos a presentar Advancing theorizing about fast-and-slow thinking, de Wim De Neys, publicado en 2023 en Behavioral and Brain Sciences. Yo les cuento cómo se investigó; después mis compañeros presentan dos aciertos y dos críticas teóricas.</a:t>
             </a:r>
             <a:endParaRPr lang="en-US" dirty="0"/>
           </a:p>
@@ -911,9 +911,10 @@
           <a:p>
             <a:r>
               <a:rPr lang="en-US" dirty="0"/>
-              <a:t>EXPOSITOR/A 5 · 0:40
-En síntesis: el artículo muestra que la exclusividad y el mecanismo de cambio son el mismo problema, y propone un modelo que conserva la distinción entre intuición y deliberación. Sus límites: es verbal, la automatización está poco probada y las tareas son artificiales.
-Y les preguntamos: ¿les pasó que algo que al principio tenían que pensar con esfuerzo, después les saliera "solo"? Por ejemplo, en estadística. Esa respuesta automática, ¿es una intuición, como dice De Neys, o sigue siendo pensamiento deliberado, pero más rápido?</a:t>
+              <a:t>TODO EL GRUPO · DEBATE, después de los 10 minutos de exposición
+Cualquiera del grupo lanza la pregunta:
+Les queremos preguntar: ¿les pasó que algo que al principio tenían que pensar con esfuerzo, después les saliera "solo"? Por ejemplo, en estadística. Esa respuesta automática, ¿es una intuición, como dice De Neys, o sigue siendo pensamiento deliberado, pero más rápido?
+[NO LEER] Si el docente pide una conclusión: el artículo muestra que la exclusividad y el mecanismo de cambio son el mismo problema, y propone un modelo que conserva la distinción entre intuición y deliberación. Sus límites: es verbal, la automatización está poco probada y las tareas son artificiales. Como líneas futuras, estudios de entrenamiento que sigan cómo una respuesta deliberada se vuelve intuitiva, y llevar el modelo a problemas reales y a dominios de pericia.</a:t>
             </a:r>
             <a:endParaRPr lang="en-US" dirty="0"/>
           </a:p>
@@ -1357,8 +1358,8 @@
           <a:p>
             <a:r>
               <a:rPr lang="en-US" dirty="0"/>
-              <a:t>EXPOSITOR/A 2 · 0:35 (parte 2: 2:00)
-A partir de esos resultados, De Neys propone un modelo. El sistema 1 activa varias intuiciones de distinta fuerza, incluida la lógica. Un monitoreo intuitivo compara esas fuerzas: si son parecidas, la incertidumbre es alta y, pasado un umbral, se activa el sistema 2. La deliberación puede corregir, pero también solo justificar. Y una retroalimentación ajusta las intuiciones y apaga la deliberación. Conclusión: todo modelo dual viable tiene que ser no exclusivo.
+              <a:t>EXPOSITOR/A 2 · 0:45 (parte 2: 2:00)
+El primer acierto es que De Neys, a diferencia de los modelos anteriores, especifica un mecanismo, y tiene cuatro piezas. El sistema 1 activa varias intuiciones de distinta fuerza, incluida la lógica: ante el bate y la pelota pueden activarse a la vez "10 centavos" y "5 centavos". Un monitoreo intuitivo compara esas fuerzas: si son parecidas, la incertidumbre es alta y, pasado un umbral, se activa el sistema 2. La deliberación puede corregir, pero también solo justificar. Y una retroalimentación ajusta las intuiciones y apaga la deliberación. Por eso concluye que todo modelo dual viable tiene que ser no exclusivo.
 [NO LEER] Si preguntan por la fórmula (ejemplo nuestro, no del texto): U = 1 − |I1 − I2|. Si la intuición "10 centavos" tiene fuerza 0,8 y la de "5 centavos" 0,3, U = 1 − 0,5 = 0,5. Si las dos valen 0,6, U = 1 − 0 = 1: máxima incertidumbre, y ahí se activa el sistema 2.
 Si preguntan por qué los modelos anteriores no explican el cambio: si el sistema 2 vigila al 1, ya tendría que estar activo para detectar el conflicto; y un "sistema 3" que los compare lleva a una regresión infinita (De Neys, 2023a, pp. 6-7).</a:t>
             </a:r>
@@ -1448,9 +1449,9 @@
           <a:p>
             <a:r>
               <a:rPr lang="en-US" dirty="0"/>
-              <a:t>EXPOSITOR/A 2 · 1:25
-El primer acierto es que hace explícito un supuesto que vimos en la materia: el de la teoría heurístico-analítica de Evans. Para Evans hay un estadio heurístico, preconsciente, que selecciona la información relevante, y uno analítico, donde se deduce. Los sesgos se atribuyen al primero y la competencia, al segundo (Valiña y Martín, 2014, pp. 19-20, 22). Esa es justamente la exclusividad, y De Neys muestra lo que a Evans le faltaba: qué hace que intervenga lo analítico. Además, que deliberar a veces solo justifique la intuición coincide con Evans: "las personas cometen errores en razonamiento porque piensan selectivamente" (Valiña y Martín, 2014, p. 20). Por ejemplo, alguien puede deliberar solo para encontrar razones a favor de los 10 centavos.
-Hay un segundo aporte. A Tversky y Kahneman se les criticó que su teoría es más descriptiva que explicativa (Pérez Echeverría y Bautista, 2014, p. 18). De Neys, en cambio, propone un mecanismo —fuerza de las intuiciones, incertidumbre, umbral y retroalimentación— del que salen preguntas que se pueden poner a prueba.</a:t>
+              <a:t>EXPOSITOR/A 2 · 1:15
+Esto llena un hueco que vimos en la materia, en la teoría heurístico-analítica de Evans. Para Evans hay un estadio heurístico, preconsciente, que selecciona la información relevante, y uno analítico, donde se deduce. Los sesgos se atribuyen al primero y la competencia, al segundo (Valiña y Martín, 2014, pp. 19-20, 22). Esa es justamente la exclusividad, y Evans no explicaba qué hace que intervenga lo analítico; De Neys sí: la incertidumbre. Además, que deliberar a veces solo justifique la intuición coincide con Evans: "las personas cometen errores en razonamiento porque piensan selectivamente" (Valiña y Martín, 2014, p. 20).
+Y responde a una crítica que vimos a Tversky y Kahneman: que su teoría es más descriptiva que explicativa (Pérez Echeverría y Bautista, 2014, p. 18). De Neys propone un proceso del que salen preguntas que se pueden poner a prueba.</a:t>
             </a:r>
             <a:endParaRPr lang="en-US" dirty="0"/>
           </a:p>
@@ -1722,11 +1723,12 @@
           <a:p>
             <a:r>
               <a:rPr lang="en-US" dirty="0"/>
-              <a:t>EXPOSITOR/A 5 · 1:20 (parte 5: 2:00)
-La segunda crítica apunta a las tareas: toda la evidencia viene de problemas de laboratorio, bien definidos y con poco contenido, como el del bate y la pelota.
-En solución de problemas, la investigación hizo el mismo camino: empezó con problemas sin contenido, que daban más control (Postigo Angón, 2014, p. 8), hasta que el enfoque de expertos y novatos mostró que resolver bien depende del conocimiento del dominio (Pérez Echeverría, 2014, p. 13). Y Pérez Echeverría advierte que estas tareas son muy artificiales y que quizás las normas matemáticas no son el mejor modelo (Pérez Echeverría y Bautista, 2014, p. 16). Entonces, ¿qué pasa con el modelo en los problemas mal definidos de la vida cotidiana, donde no hay respuesta correcta contra la cual medir? El autor lo admite como límite (De Neys, 2023b, p. 68).
-Además, que la lógica se automatice tiene poca evidencia directa (De Neys, 2023a, p. 13), y el autor no usa la tradición de Fischbein, que podría darle sustento.
-[NO LEER] Si preguntan qué sería "acertar" fuera del laboratorio: Evans distingue la racionalidad de proceso, ajustarse a una norma como la lógica, de la racionalidad de propósito, alcanzar los propios objetivos (Valiña y Martín, 2014, p. 21). En la vida cotidiana importa la segunda, y el modelo solo mide la primera.</a:t>
+              <a:t>EXPOSITOR/A 5 · 2:00
+La segunda crítica apunta a las tareas: toda la evidencia viene de problemas de laboratorio, bien definidos y con poco contenido, como el del bate y la pelota o elegir entre bandejas con bolitas.
+En solución de problemas, la investigación hizo el mismo camino: empezó con problemas sin contenido, que daban más control experimental (Postigo Angón, 2014, p. 8), hasta que el enfoque de expertos y novatos mostró que resolver bien depende del conocimiento del dominio (Pérez Echeverría, 2014, p. 13). Y Pérez Echeverría advierte que estas tareas son muy artificiales y que quizás las normas matemáticas no son el mejor modelo (Pérez Echeverría y Bautista, 2014, p. 16).
+Entonces, ¿qué pasa con el modelo en los problemas mal definidos de la vida cotidiana, donde no hay una respuesta correcta contra la cual medir la intuición? Evans distingue la racionalidad de proceso, ajustarse a una norma como la lógica, de la racionalidad de propósito, alcanzar los propios objetivos (Valiña y Martín, 2014, p. 21). El modelo de De Neys solo mide la primera, y el propio autor admite este límite (De Neys, 2023b, p. 68).
+Por último, la pieza más original del modelo, que la respuesta lógica se automatice, tiene poca evidencia directa (De Neys, 2023a, p. 13). Y el autor no recurre a la tradición de Fischbein, que estudió justamente cómo la instrucción genera intuiciones nuevas y podría darle sustento.
+Con esto terminamos la exposición. Ahora queremos abrir el debate.</a:t>
             </a:r>
             <a:endParaRPr lang="en-US" dirty="0"/>
           </a:p>
@@ -2862,7 +2864,7 @@
                   <a:schemeClr val="bg1"/>
                 </a:solidFill>
               </a:rPr>
-              <a:t>Propuesta y aciertos</a:t>
+              <a:t>Aciertos teóricos</a:t>
             </a:r>
             <a:endParaRPr lang="en-US" sz="1500" dirty="0"/>
           </a:p>
@@ -6077,7 +6079,7 @@
         <p:spPr>
           <a:xfrm>
             <a:off x="457200" y="201168"/>
-            <a:ext cx="1664208" cy="274320"/>
+            <a:ext cx="1463040" cy="274320"/>
           </a:xfrm>
           <a:prstGeom prst="roundRect">
             <a:avLst>
@@ -6104,7 +6106,7 @@
         <p:spPr>
           <a:xfrm>
             <a:off x="457200" y="201168"/>
-            <a:ext cx="1664208" cy="274320"/>
+            <a:ext cx="1463040" cy="274320"/>
           </a:xfrm>
           <a:prstGeom prst="rect">
             <a:avLst/>
@@ -6125,7 +6127,7 @@
                   <a:schemeClr val="bg1"/>
                 </a:solidFill>
               </a:rPr>
-              <a:t>LA PROPUESTA</a:t>
+              <a:t>ACIERTO 1</a:t>
             </a:r>
             <a:endParaRPr lang="en-US" sz="1100" dirty="0"/>
           </a:p>
@@ -6163,7 +6165,7 @@
                   <a:schemeClr val="tx1"/>
                 </a:solidFill>
               </a:rPr>
-              <a:t>La propuesta: un modelo no exclusivo</a:t>
+              <a:t>Un mecanismo explícito, en cuatro piezas</a:t>
             </a:r>
             <a:endParaRPr lang="en-US" sz="2800" dirty="0"/>
           </a:p>
@@ -7123,7 +7125,7 @@
                   <a:schemeClr val="tx1"/>
                 </a:solidFill>
               </a:rPr>
-              <a:t>Un mecanismo donde Evans no lo tenía</a:t>
+              <a:t>Lo que a Evans le faltaba</a:t>
             </a:r>
             <a:endParaRPr lang="en-US" sz="2800" dirty="0"/>
           </a:p>
@@ -9597,7 +9599,7 @@
                   <a:schemeClr val="tx1"/>
                 </a:solidFill>
               </a:rPr>
-              <a:t>Resolver depende del conocimiento del dominio (expertos y novatos). En la vida cotidiana, ¿contra qué norma se mide el acierto?</a:t>
+              <a:t>Resolver depende del conocimiento del dominio (expertos y novatos). Y fuera del laboratorio importa la racionalidad de propósito, no solo la de proceso (Evans).</a:t>
             </a:r>
             <a:endParaRPr lang="en-US" sz="1300" dirty="0"/>
           </a:p>
@@ -9758,7 +9760,7 @@
                   <a:schemeClr val="tx2"/>
                 </a:solidFill>
               </a:rPr>
-              <a:t>Postigo Angón (2014, p. 8); Pérez Echeverría (2014, p. 13); Pérez Echeverría y Bautista (2014, p. 16); De Neys (2023a, p. 13; 2023b, p. 68)</a:t>
+              <a:t>Postigo Angón (2014, p. 8); Pérez Echeverría (2014, p. 13); Pérez Echeverría y Bautista (2014, p. 16); Valiña y Martín (2014, p. 21); De Neys (2023a, p. 13; 2023b, p. 68)</a:t>
             </a:r>
             <a:endParaRPr lang="en-US" sz="1000" dirty="0"/>
           </a:p>

</xml_diff>